<commit_message>
v1.1.1: aplicación desplegada en Streamlit Community Cloud (genial-clasificador.streamlit.app); enlace en README y manual; QR de la app en la diapositiva 9 del pitch
Co-Authored-By: Claude Fable 5.1 <noreply@anthropic.com>
Claude-Session: https://claude.ai/code/session_01WoNHoUaGaerBW2JnaGJH3V
</commit_message>
<xml_diff>
--- a/results/reports/proyecto_final/Grupo_9_Video_Pitch_5min.pptx
+++ b/results/reports/proyecto_final/Grupo_9_Video_Pitch_5min.pptx
@@ -11894,18 +11894,121 @@
           </a:solidFill>
           <a:ln w="19050">
             <a:solidFill>
-              <a:srgbClr val="E8CFD8"/>
+              <a:srgbClr val="FFFFFF"/>
             </a:solidFill>
-            <a:prstDash val="dash"/>
+            <a:prstDash val="solid"/>
           </a:ln>
         </p:spPr>
       </p:sp>
       <p:sp>
         <p:nvSpPr>
-          <p:cNvPr id="16" name="Text 13"/>
-          <p:cNvSpPr txBox="1"/>
-          <p:nvPr/>
-        </p:nvSpPr>
+          <p:cNvPr id="17" name="Text 14"/>
+          <p:cNvSpPr txBox="1"/>
+          <p:nvPr/>
+        </p:nvSpPr>
+        <p:spPr>
+          <a:xfrm>
+            <a:off x="10149840" y="2743200"/>
+            <a:ext cx="2103120" cy="777240"/>
+          </a:xfrm>
+          <a:prstGeom prst="rect">
+            <a:avLst/>
+          </a:prstGeom>
+          <a:noFill/>
+          <a:ln/>
+        </p:spPr>
+        <p:txBody>
+          <a:bodyPr wrap="square" lIns="0" tIns="0" rIns="0" bIns="0" rtlCol="0" anchor="t"/>
+          <a:lstStyle/>
+          <a:p>
+            <a:pPr algn="ctr" indent="0" marL="0">
+              <a:buNone/>
+            </a:pPr>
+            <a:r>
+              <a:rPr lang="en-US" sz="1100" b="1" dirty="0">
+                <a:solidFill>
+                  <a:srgbClr val="1B1A19"/>
+                </a:solidFill>
+                <a:latin typeface="Calibri" pitchFamily="34" charset="0"/>
+                <a:ea typeface="Calibri" pitchFamily="34" charset="-122"/>
+                <a:cs typeface="Calibri" pitchFamily="34" charset="-120"/>
+              </a:rPr>
+              <a:t>Aplicación web</a:t>
+            </a:r>
+            <a:endParaRPr lang="en-US" sz="1100" dirty="0"/>
+          </a:p>
+          <a:p>
+            <a:pPr algn="ctr" indent="0" marL="0">
+              <a:buNone/>
+            </a:pPr>
+            <a:r>
+              <a:rPr lang="en-US" sz="850" dirty="0">
+                <a:solidFill>
+                  <a:srgbClr val="6E6862"/>
+                </a:solidFill>
+                <a:latin typeface="Calibri" pitchFamily="34" charset="0"/>
+                <a:ea typeface="Calibri" pitchFamily="34" charset="-122"/>
+                <a:cs typeface="Calibri" pitchFamily="34" charset="-120"/>
+              </a:rPr>
+              <a:t>genial-clasificador.streamlit.app</a:t>
+            </a:r>
+            <a:endParaRPr lang="en-US" sz="1100" dirty="0"/>
+          </a:p>
+        </p:txBody>
+      </p:sp>
+      <p:sp>
+        <p:nvSpPr>
+          <p:cNvPr id="18" name="Text 15"/>
+          <p:cNvSpPr txBox="1"/>
+          <p:nvPr/>
+        </p:nvSpPr>
+        <p:spPr>
+          <a:xfrm>
+            <a:off x="548640" y="6217920"/>
+            <a:ext cx="11094415" cy="365760"/>
+          </a:xfrm>
+          <a:prstGeom prst="rect">
+            <a:avLst/>
+          </a:prstGeom>
+          <a:noFill/>
+          <a:ln/>
+        </p:spPr>
+        <p:txBody>
+          <a:bodyPr wrap="square" lIns="0" tIns="0" rIns="0" bIns="0" rtlCol="0" anchor="ctr"/>
+          <a:lstStyle/>
+          <a:p>
+            <a:pPr indent="0" marL="0">
+              <a:buNone/>
+            </a:pPr>
+            <a:r>
+              <a:rPr lang="en-US" sz="1200" dirty="0">
+                <a:solidFill>
+                  <a:srgbClr val="E8CFD8"/>
+                </a:solidFill>
+                <a:latin typeface="Calibri" pitchFamily="34" charset="0"/>
+                <a:ea typeface="Calibri" pitchFamily="34" charset="-122"/>
+                <a:cs typeface="Calibri" pitchFamily="34" charset="-120"/>
+              </a:rPr>
+              <a:t>Jorge Javier Maldonado Mahauad · Melissa Figallo · Grupo 9 · Maestría en IA · UEES · 2026 · Gracias</a:t>
+            </a:r>
+            <a:endParaRPr lang="en-US" sz="1200" dirty="0"/>
+          </a:p>
+        </p:txBody>
+      </p:sp>
+      <p:pic>
+        <p:nvPicPr>
+          <p:cNvPr id="19" name="Picture 18" descr="qr_app.png"/>
+          <p:cNvPicPr>
+            <a:picLocks noChangeAspect="1"/>
+          </p:cNvPicPr>
+          <p:nvPr/>
+        </p:nvPicPr>
+        <p:blipFill>
+          <a:blip r:embed="rId4"/>
+          <a:stretch>
+            <a:fillRect/>
+          </a:stretch>
+        </p:blipFill>
         <p:spPr>
           <a:xfrm>
             <a:off x="10287000" y="914400"/>
@@ -11914,143 +12017,8 @@
           <a:prstGeom prst="rect">
             <a:avLst/>
           </a:prstGeom>
-          <a:noFill/>
-          <a:ln/>
-        </p:spPr>
-        <p:txBody>
-          <a:bodyPr wrap="square" lIns="0" tIns="0" rIns="0" bIns="0" rtlCol="0" anchor="ctr"/>
-          <a:lstStyle/>
-          <a:p>
-            <a:pPr algn="ctr" indent="0" marL="0">
-              <a:buNone/>
-            </a:pPr>
-            <a:r>
-              <a:rPr lang="en-US" sz="900" dirty="0">
-                <a:solidFill>
-                  <a:srgbClr val="6E6862"/>
-                </a:solidFill>
-                <a:latin typeface="Calibri" pitchFamily="34" charset="0"/>
-                <a:ea typeface="Calibri" pitchFamily="34" charset="-122"/>
-                <a:cs typeface="Calibri" pitchFamily="34" charset="-120"/>
-              </a:rPr>
-              <a:t>QR de la aplicación</a:t>
-            </a:r>
-            <a:endParaRPr lang="en-US" sz="900" dirty="0"/>
-          </a:p>
-          <a:p>
-            <a:pPr algn="ctr" indent="0" marL="0">
-              <a:buNone/>
-            </a:pPr>
-            <a:r>
-              <a:rPr lang="en-US" sz="900" dirty="0">
-                <a:solidFill>
-                  <a:srgbClr val="6E6862"/>
-                </a:solidFill>
-                <a:latin typeface="Calibri" pitchFamily="34" charset="0"/>
-                <a:ea typeface="Calibri" pitchFamily="34" charset="-122"/>
-                <a:cs typeface="Calibri" pitchFamily="34" charset="-120"/>
-              </a:rPr>
-              <a:t>(se genera al publicar en Streamlit Community Cloud)</a:t>
-            </a:r>
-            <a:endParaRPr lang="en-US" sz="900" dirty="0"/>
-          </a:p>
-        </p:txBody>
-      </p:sp>
-      <p:sp>
-        <p:nvSpPr>
-          <p:cNvPr id="17" name="Text 14"/>
-          <p:cNvSpPr txBox="1"/>
-          <p:nvPr/>
-        </p:nvSpPr>
-        <p:spPr>
-          <a:xfrm>
-            <a:off x="10149840" y="2743200"/>
-            <a:ext cx="2103120" cy="777240"/>
-          </a:xfrm>
-          <a:prstGeom prst="rect">
-            <a:avLst/>
-          </a:prstGeom>
-          <a:noFill/>
-          <a:ln/>
-        </p:spPr>
-        <p:txBody>
-          <a:bodyPr wrap="square" lIns="0" tIns="0" rIns="0" bIns="0" rtlCol="0" anchor="t"/>
-          <a:lstStyle/>
-          <a:p>
-            <a:pPr algn="ctr" indent="0" marL="0">
-              <a:buNone/>
-            </a:pPr>
-            <a:r>
-              <a:rPr lang="en-US" sz="1100" b="1" dirty="0">
-                <a:solidFill>
-                  <a:srgbClr val="1B1A19"/>
-                </a:solidFill>
-                <a:latin typeface="Calibri" pitchFamily="34" charset="0"/>
-                <a:ea typeface="Calibri" pitchFamily="34" charset="-122"/>
-                <a:cs typeface="Calibri" pitchFamily="34" charset="-120"/>
-              </a:rPr>
-              <a:t>Aplicación web</a:t>
-            </a:r>
-            <a:endParaRPr lang="en-US" sz="1100" dirty="0"/>
-          </a:p>
-          <a:p>
-            <a:pPr algn="ctr" indent="0" marL="0">
-              <a:buNone/>
-            </a:pPr>
-            <a:r>
-              <a:rPr lang="en-US" sz="850" dirty="0">
-                <a:solidFill>
-                  <a:srgbClr val="6E6862"/>
-                </a:solidFill>
-                <a:latin typeface="Calibri" pitchFamily="34" charset="0"/>
-                <a:ea typeface="Calibri" pitchFamily="34" charset="-122"/>
-                <a:cs typeface="Calibri" pitchFamily="34" charset="-120"/>
-              </a:rPr>
-              <a:t>…streamlit.app</a:t>
-            </a:r>
-            <a:endParaRPr lang="en-US" sz="1100" dirty="0"/>
-          </a:p>
-        </p:txBody>
-      </p:sp>
-      <p:sp>
-        <p:nvSpPr>
-          <p:cNvPr id="18" name="Text 15"/>
-          <p:cNvSpPr txBox="1"/>
-          <p:nvPr/>
-        </p:nvSpPr>
-        <p:spPr>
-          <a:xfrm>
-            <a:off x="548640" y="6217920"/>
-            <a:ext cx="11094415" cy="365760"/>
-          </a:xfrm>
-          <a:prstGeom prst="rect">
-            <a:avLst/>
-          </a:prstGeom>
-          <a:noFill/>
-          <a:ln/>
-        </p:spPr>
-        <p:txBody>
-          <a:bodyPr wrap="square" lIns="0" tIns="0" rIns="0" bIns="0" rtlCol="0" anchor="ctr"/>
-          <a:lstStyle/>
-          <a:p>
-            <a:pPr indent="0" marL="0">
-              <a:buNone/>
-            </a:pPr>
-            <a:r>
-              <a:rPr lang="en-US" sz="1200" dirty="0">
-                <a:solidFill>
-                  <a:srgbClr val="E8CFD8"/>
-                </a:solidFill>
-                <a:latin typeface="Calibri" pitchFamily="34" charset="0"/>
-                <a:ea typeface="Calibri" pitchFamily="34" charset="-122"/>
-                <a:cs typeface="Calibri" pitchFamily="34" charset="-120"/>
-              </a:rPr>
-              <a:t>Jorge Javier Maldonado Mahauad · Melissa Figallo · Grupo 9 · Maestría en IA · UEES · 2026 · Gracias</a:t>
-            </a:r>
-            <a:endParaRPr lang="en-US" sz="1200" dirty="0"/>
-          </a:p>
-        </p:txBody>
-      </p:sp>
+        </p:spPr>
+      </p:pic>
     </p:spTree>
   </p:cSld>
   <p:clrMapOvr>

</xml_diff>